<commit_message>
docs: reviewer-friendly README + ERC-8183/8004 + Gateway in pitch deck
- README: add 'For reviewers' verification table linking to live ERC-8183/8004
  contracts, Job #4 createJob/submit/complete txs (reputation 0→1 verified
  on-chain), tx-evidence file, and bootstrap-agent-eoa.mjs
- README: replace ASCII architecture diagrams with mermaid (renders natively
  on GitHub)
- README: document bootstrap-agent-eoa.mjs in Getting Started
- pitch-deck: expand slide 5 from 4→6 cards covering ERC-8183
  AgenticCommerce, ERC-8004 IdentityRegistry, and Circle Gateway — the
  three differentiating primitives missing in the prior deck
</commit_message>
<xml_diff>
--- a/slides/pitch-deck.pptx
+++ b/slides/pitch-deck.pptx
@@ -4848,8 +4848,8 @@
         </p:nvSpPr>
         <p:spPr>
           <a:xfrm>
-            <a:off x="731520" y="1371600"/>
-            <a:ext cx="3703320" cy="1417320"/>
+            <a:off x="731520" y="1280160"/>
+            <a:ext cx="3703320" cy="960120"/>
           </a:xfrm>
           <a:prstGeom prst="rect">
             <a:avLst/>
@@ -4875,8 +4875,8 @@
         </p:nvSpPr>
         <p:spPr>
           <a:xfrm>
-            <a:off x="731520" y="1371600"/>
-            <a:ext cx="64008" cy="1417320"/>
+            <a:off x="731520" y="1280160"/>
+            <a:ext cx="64008" cy="960120"/>
           </a:xfrm>
           <a:prstGeom prst="rect">
             <a:avLst/>
@@ -4895,8 +4895,8 @@
         </p:nvSpPr>
         <p:spPr>
           <a:xfrm>
-            <a:off x="1005840" y="1508760"/>
-            <a:ext cx="3200400" cy="411480"/>
+            <a:off x="1005840" y="1371600"/>
+            <a:ext cx="3200400" cy="320040"/>
           </a:xfrm>
           <a:prstGeom prst="rect">
             <a:avLst/>
@@ -4912,7 +4912,7 @@
               <a:buNone/>
             </a:pPr>
             <a:r>
-              <a:rPr lang="en-US" sz="2000" b="1" dirty="0">
+              <a:rPr lang="en-US" sz="1500" b="1" dirty="0">
                 <a:solidFill>
                   <a:srgbClr val="FFFFFF"/>
                 </a:solidFill>
@@ -4920,9 +4920,9 @@
                 <a:ea typeface="Calibri" pitchFamily="34" charset="-122"/>
                 <a:cs typeface="Calibri" pitchFamily="34" charset="-120"/>
               </a:rPr>
-              <a:t>Native USDC</a:t>
-            </a:r>
-            <a:endParaRPr lang="en-US" sz="2000" dirty="0"/>
+              <a:t>Native USDC + EIP-3009</a:t>
+            </a:r>
+            <a:endParaRPr lang="en-US" sz="1500" dirty="0"/>
           </a:p>
         </p:txBody>
       </p:sp>
@@ -4934,8 +4934,8 @@
         </p:nvSpPr>
         <p:spPr>
           <a:xfrm>
-            <a:off x="1005840" y="1965960"/>
-            <a:ext cx="3200400" cy="685800"/>
+            <a:off x="1005840" y="1719072"/>
+            <a:ext cx="3200400" cy="502920"/>
           </a:xfrm>
           <a:prstGeom prst="rect">
             <a:avLst/>
@@ -4951,7 +4951,7 @@
               <a:buNone/>
             </a:pPr>
             <a:r>
-              <a:rPr lang="en-US" sz="1300" dirty="0">
+              <a:rPr lang="en-US" sz="1100" dirty="0">
                 <a:solidFill>
                   <a:srgbClr val="94A3B8"/>
                 </a:solidFill>
@@ -4959,16 +4959,16 @@
                 <a:ea typeface="Calibri" pitchFamily="34" charset="-122"/>
                 <a:cs typeface="Calibri" pitchFamily="34" charset="-120"/>
               </a:rPr>
-              <a:t>$0.001 micropayments economically viable.</a:t>
-            </a:r>
-            <a:endParaRPr lang="en-US" sz="1300" dirty="0"/>
+              <a:t>$0.001 micropayments via gas-free</a:t>
+            </a:r>
+            <a:endParaRPr lang="en-US" sz="1100" dirty="0"/>
           </a:p>
           <a:p>
             <a:pPr algn="l" indent="0" marL="0">
               <a:buNone/>
             </a:pPr>
             <a:r>
-              <a:rPr lang="en-US" sz="1300" dirty="0">
+              <a:rPr lang="en-US" sz="1100" dirty="0">
                 <a:solidFill>
                   <a:srgbClr val="94A3B8"/>
                 </a:solidFill>
@@ -4976,9 +4976,9 @@
                 <a:ea typeface="Calibri" pitchFamily="34" charset="-122"/>
                 <a:cs typeface="Calibri" pitchFamily="34" charset="-120"/>
               </a:rPr>
-              <a:t>No bridge overhead, no wrapped tokens.</a:t>
-            </a:r>
-            <a:endParaRPr lang="en-US" sz="1300" dirty="0"/>
+              <a:t>TransferWithAuthorization meta-tx.</a:t>
+            </a:r>
+            <a:endParaRPr lang="en-US" sz="1100" dirty="0"/>
           </a:p>
         </p:txBody>
       </p:sp>
@@ -4990,8 +4990,8 @@
         </p:nvSpPr>
         <p:spPr>
           <a:xfrm>
-            <a:off x="4709160" y="1371600"/>
-            <a:ext cx="3703320" cy="1417320"/>
+            <a:off x="4709160" y="1280160"/>
+            <a:ext cx="3703320" cy="960120"/>
           </a:xfrm>
           <a:prstGeom prst="rect">
             <a:avLst/>
@@ -5017,8 +5017,8 @@
         </p:nvSpPr>
         <p:spPr>
           <a:xfrm>
-            <a:off x="4709160" y="1371600"/>
-            <a:ext cx="64008" cy="1417320"/>
+            <a:off x="4709160" y="1280160"/>
+            <a:ext cx="64008" cy="960120"/>
           </a:xfrm>
           <a:prstGeom prst="rect">
             <a:avLst/>
@@ -5037,8 +5037,8 @@
         </p:nvSpPr>
         <p:spPr>
           <a:xfrm>
-            <a:off x="4983480" y="1508760"/>
-            <a:ext cx="3200400" cy="411480"/>
+            <a:off x="4983480" y="1371600"/>
+            <a:ext cx="3200400" cy="320040"/>
           </a:xfrm>
           <a:prstGeom prst="rect">
             <a:avLst/>
@@ -5054,7 +5054,7 @@
               <a:buNone/>
             </a:pPr>
             <a:r>
-              <a:rPr lang="en-US" sz="2000" b="1" dirty="0">
+              <a:rPr lang="en-US" sz="1500" b="1" dirty="0">
                 <a:solidFill>
                   <a:srgbClr val="FFFFFF"/>
                 </a:solidFill>
@@ -5062,9 +5062,9 @@
                 <a:ea typeface="Calibri" pitchFamily="34" charset="-122"/>
                 <a:cs typeface="Calibri" pitchFamily="34" charset="-120"/>
               </a:rPr>
-              <a:t>x402 Protocol</a:t>
-            </a:r>
-            <a:endParaRPr lang="en-US" sz="2000" dirty="0"/>
+              <a:t>x402 Pay-Per-Result</a:t>
+            </a:r>
+            <a:endParaRPr lang="en-US" sz="1500" dirty="0"/>
           </a:p>
         </p:txBody>
       </p:sp>
@@ -5076,8 +5076,8 @@
         </p:nvSpPr>
         <p:spPr>
           <a:xfrm>
-            <a:off x="4983480" y="1965960"/>
-            <a:ext cx="3200400" cy="685800"/>
+            <a:off x="4983480" y="1719072"/>
+            <a:ext cx="3200400" cy="502920"/>
           </a:xfrm>
           <a:prstGeom prst="rect">
             <a:avLst/>
@@ -5093,7 +5093,7 @@
               <a:buNone/>
             </a:pPr>
             <a:r>
-              <a:rPr lang="en-US" sz="1300" dirty="0">
+              <a:rPr lang="en-US" sz="1100" dirty="0">
                 <a:solidFill>
                   <a:srgbClr val="94A3B8"/>
                 </a:solidFill>
@@ -5101,16 +5101,16 @@
                 <a:ea typeface="Calibri" pitchFamily="34" charset="-122"/>
                 <a:cs typeface="Calibri" pitchFamily="34" charset="-120"/>
               </a:rPr>
-              <a:t>HTTP 402 payment-gated API responses.</a:t>
-            </a:r>
-            <a:endParaRPr lang="en-US" sz="1300" dirty="0"/>
+              <a:t>HTTP 402 gates each iteration.</a:t>
+            </a:r>
+            <a:endParaRPr lang="en-US" sz="1100" dirty="0"/>
           </a:p>
           <a:p>
             <a:pPr algn="l" indent="0" marL="0">
               <a:buNone/>
             </a:pPr>
             <a:r>
-              <a:rPr lang="en-US" sz="1300" dirty="0">
+              <a:rPr lang="en-US" sz="1100" dirty="0">
                 <a:solidFill>
                   <a:srgbClr val="94A3B8"/>
                 </a:solidFill>
@@ -5118,9 +5118,9 @@
                 <a:ea typeface="Calibri" pitchFamily="34" charset="-122"/>
                 <a:cs typeface="Calibri" pitchFamily="34" charset="-120"/>
               </a:rPr>
-              <a:t>Pay-per-call, not pay-per-month.</a:t>
-            </a:r>
-            <a:endParaRPr lang="en-US" sz="1300" dirty="0"/>
+              <a:t>No subscriptions; unlock on demand.</a:t>
+            </a:r>
+            <a:endParaRPr lang="en-US" sz="1100" dirty="0"/>
           </a:p>
         </p:txBody>
       </p:sp>
@@ -5132,8 +5132,8 @@
         </p:nvSpPr>
         <p:spPr>
           <a:xfrm>
-            <a:off x="731520" y="3063240"/>
-            <a:ext cx="3703320" cy="1417320"/>
+            <a:off x="731520" y="2423160"/>
+            <a:ext cx="3703320" cy="960120"/>
           </a:xfrm>
           <a:prstGeom prst="rect">
             <a:avLst/>
@@ -5159,8 +5159,8 @@
         </p:nvSpPr>
         <p:spPr>
           <a:xfrm>
-            <a:off x="731520" y="3063240"/>
-            <a:ext cx="64008" cy="1417320"/>
+            <a:off x="731520" y="2423160"/>
+            <a:ext cx="64008" cy="960120"/>
           </a:xfrm>
           <a:prstGeom prst="rect">
             <a:avLst/>
@@ -5179,8 +5179,8 @@
         </p:nvSpPr>
         <p:spPr>
           <a:xfrm>
-            <a:off x="1005840" y="3200400"/>
-            <a:ext cx="3200400" cy="411480"/>
+            <a:off x="1005840" y="2514600"/>
+            <a:ext cx="3200400" cy="320040"/>
           </a:xfrm>
           <a:prstGeom prst="rect">
             <a:avLst/>
@@ -5196,7 +5196,7 @@
               <a:buNone/>
             </a:pPr>
             <a:r>
-              <a:rPr lang="en-US" sz="2000" b="1" dirty="0">
+              <a:rPr lang="en-US" sz="1500" b="1" dirty="0">
                 <a:solidFill>
                   <a:srgbClr val="FFFFFF"/>
                 </a:solidFill>
@@ -5204,9 +5204,9 @@
                 <a:ea typeface="Calibri" pitchFamily="34" charset="-122"/>
                 <a:cs typeface="Calibri" pitchFamily="34" charset="-120"/>
               </a:rPr>
-              <a:t>EIP-3009 Meta-TX</a:t>
-            </a:r>
-            <a:endParaRPr lang="en-US" sz="2000" dirty="0"/>
+              <a:t>ERC-8183 AgenticCommerce</a:t>
+            </a:r>
+            <a:endParaRPr lang="en-US" sz="1500" dirty="0"/>
           </a:p>
         </p:txBody>
       </p:sp>
@@ -5218,8 +5218,8 @@
         </p:nvSpPr>
         <p:spPr>
           <a:xfrm>
-            <a:off x="1005840" y="3657600"/>
-            <a:ext cx="3200400" cy="685800"/>
+            <a:off x="1005840" y="2862072"/>
+            <a:ext cx="3200400" cy="502920"/>
           </a:xfrm>
           <a:prstGeom prst="rect">
             <a:avLst/>
@@ -5235,7 +5235,7 @@
               <a:buNone/>
             </a:pPr>
             <a:r>
-              <a:rPr lang="en-US" sz="1300" dirty="0">
+              <a:rPr lang="en-US" sz="1100" dirty="0">
                 <a:solidFill>
                   <a:srgbClr val="94A3B8"/>
                 </a:solidFill>
@@ -5243,16 +5243,16 @@
                 <a:ea typeface="Calibri" pitchFamily="34" charset="-122"/>
                 <a:cs typeface="Calibri" pitchFamily="34" charset="-120"/>
               </a:rPr>
-              <a:t>Gas-free client experience.</a:t>
-            </a:r>
-            <a:endParaRPr lang="en-US" sz="1300" dirty="0"/>
+              <a:t>On-chain Job lifecycle:</a:t>
+            </a:r>
+            <a:endParaRPr lang="en-US" sz="1100" dirty="0"/>
           </a:p>
           <a:p>
             <a:pPr algn="l" indent="0" marL="0">
               <a:buNone/>
             </a:pPr>
             <a:r>
-              <a:rPr lang="en-US" sz="1300" dirty="0">
+              <a:rPr lang="en-US" sz="1100" dirty="0">
                 <a:solidFill>
                   <a:srgbClr val="94A3B8"/>
                 </a:solidFill>
@@ -5260,9 +5260,9 @@
                 <a:ea typeface="Calibri" pitchFamily="34" charset="-122"/>
                 <a:cs typeface="Calibri" pitchFamily="34" charset="-120"/>
               </a:rPr>
-              <a:t>Relay wallet submits on-chain.</a:t>
-            </a:r>
-            <a:endParaRPr lang="en-US" sz="1300" dirty="0"/>
+              <a:t>createJob → submit → complete.</a:t>
+            </a:r>
+            <a:endParaRPr lang="en-US" sz="1100" dirty="0"/>
           </a:p>
         </p:txBody>
       </p:sp>
@@ -5274,8 +5274,8 @@
         </p:nvSpPr>
         <p:spPr>
           <a:xfrm>
-            <a:off x="4709160" y="3063240"/>
-            <a:ext cx="3703320" cy="1417320"/>
+            <a:off x="4709160" y="2423160"/>
+            <a:ext cx="3703320" cy="960120"/>
           </a:xfrm>
           <a:prstGeom prst="rect">
             <a:avLst/>
@@ -5301,8 +5301,8 @@
         </p:nvSpPr>
         <p:spPr>
           <a:xfrm>
-            <a:off x="4709160" y="3063240"/>
-            <a:ext cx="64008" cy="1417320"/>
+            <a:off x="4709160" y="2423160"/>
+            <a:ext cx="64008" cy="960120"/>
           </a:xfrm>
           <a:prstGeom prst="rect">
             <a:avLst/>
@@ -5321,8 +5321,8 @@
         </p:nvSpPr>
         <p:spPr>
           <a:xfrm>
-            <a:off x="4983480" y="3200400"/>
-            <a:ext cx="3200400" cy="411480"/>
+            <a:off x="4983480" y="2514600"/>
+            <a:ext cx="3200400" cy="320040"/>
           </a:xfrm>
           <a:prstGeom prst="rect">
             <a:avLst/>
@@ -5338,7 +5338,7 @@
               <a:buNone/>
             </a:pPr>
             <a:r>
-              <a:rPr lang="en-US" sz="2000" b="1" dirty="0">
+              <a:rPr lang="en-US" sz="1500" b="1" dirty="0">
                 <a:solidFill>
                   <a:srgbClr val="FFFFFF"/>
                 </a:solidFill>
@@ -5346,9 +5346,9 @@
                 <a:ea typeface="Calibri" pitchFamily="34" charset="-122"/>
                 <a:cs typeface="Calibri" pitchFamily="34" charset="-120"/>
               </a:rPr>
-              <a:t>Agent Reputation</a:t>
-            </a:r>
-            <a:endParaRPr lang="en-US" sz="2000" dirty="0"/>
+              <a:t>ERC-8004 IdentityRegistry</a:t>
+            </a:r>
+            <a:endParaRPr lang="en-US" sz="1500" dirty="0"/>
           </a:p>
         </p:txBody>
       </p:sp>
@@ -5360,8 +5360,8 @@
         </p:nvSpPr>
         <p:spPr>
           <a:xfrm>
-            <a:off x="4983480" y="3657600"/>
-            <a:ext cx="3200400" cy="685800"/>
+            <a:off x="4983480" y="2862072"/>
+            <a:ext cx="3200400" cy="502920"/>
           </a:xfrm>
           <a:prstGeom prst="rect">
             <a:avLst/>
@@ -5377,7 +5377,7 @@
               <a:buNone/>
             </a:pPr>
             <a:r>
-              <a:rPr lang="en-US" sz="1300" dirty="0">
+              <a:rPr lang="en-US" sz="1100" dirty="0">
                 <a:solidFill>
                   <a:srgbClr val="94A3B8"/>
                 </a:solidFill>
@@ -5385,16 +5385,16 @@
                 <a:ea typeface="Calibri" pitchFamily="34" charset="-122"/>
                 <a:cs typeface="Calibri" pitchFamily="34" charset="-120"/>
               </a:rPr>
-              <a:t>On-chain leaderboard incentivizes</a:t>
-            </a:r>
-            <a:endParaRPr lang="en-US" sz="1300" dirty="0"/>
+              <a:t>Reputation grows verifiably:</a:t>
+            </a:r>
+            <a:endParaRPr lang="en-US" sz="1100" dirty="0"/>
           </a:p>
           <a:p>
             <a:pPr algn="l" indent="0" marL="0">
               <a:buNone/>
             </a:pPr>
             <a:r>
-              <a:rPr lang="en-US" sz="1300" dirty="0">
+              <a:rPr lang="en-US" sz="1100" dirty="0">
                 <a:solidFill>
                   <a:srgbClr val="94A3B8"/>
                 </a:solidFill>
@@ -5402,9 +5402,293 @@
                 <a:ea typeface="Calibri" pitchFamily="34" charset="-122"/>
                 <a:cs typeface="Calibri" pitchFamily="34" charset="-120"/>
               </a:rPr>
-              <a:t>worker network growth.</a:t>
-            </a:r>
-            <a:endParaRPr lang="en-US" sz="1300" dirty="0"/>
+              <a:t>complete() → incrementReputation().</a:t>
+            </a:r>
+            <a:endParaRPr lang="en-US" sz="1100" dirty="0"/>
+          </a:p>
+        </p:txBody>
+      </p:sp>
+      <p:sp>
+        <p:nvSpPr>
+          <p:cNvPr id="20" name="Shape 18"/>
+          <p:cNvSpPr/>
+          <p:nvPr/>
+        </p:nvSpPr>
+        <p:spPr>
+          <a:xfrm>
+            <a:off x="731520" y="3566160"/>
+            <a:ext cx="3703320" cy="960120"/>
+          </a:xfrm>
+          <a:prstGeom prst="rect">
+            <a:avLst/>
+          </a:prstGeom>
+          <a:solidFill>
+            <a:srgbClr val="141937"/>
+          </a:solidFill>
+          <a:ln/>
+          <a:effectLst>
+            <a:outerShdw sx="100000" sy="100000" kx="0" ky="0" algn="bl" rotWithShape="0" blurRad="101600" dist="38100" dir="8100000">
+              <a:srgbClr val="000000">
+                <a:alpha val="30000"/>
+              </a:srgbClr>
+            </a:outerShdw>
+          </a:effectLst>
+        </p:spPr>
+      </p:sp>
+      <p:sp>
+        <p:nvSpPr>
+          <p:cNvPr id="21" name="Shape 19"/>
+          <p:cNvSpPr/>
+          <p:nvPr/>
+        </p:nvSpPr>
+        <p:spPr>
+          <a:xfrm>
+            <a:off x="731520" y="3566160"/>
+            <a:ext cx="64008" cy="960120"/>
+          </a:xfrm>
+          <a:prstGeom prst="rect">
+            <a:avLst/>
+          </a:prstGeom>
+          <a:solidFill>
+            <a:srgbClr val="7C3AED"/>
+          </a:solidFill>
+          <a:ln/>
+        </p:spPr>
+      </p:sp>
+      <p:sp>
+        <p:nvSpPr>
+          <p:cNvPr id="22" name="Text 20"/>
+          <p:cNvSpPr/>
+          <p:nvPr/>
+        </p:nvSpPr>
+        <p:spPr>
+          <a:xfrm>
+            <a:off x="1005840" y="3657600"/>
+            <a:ext cx="3200400" cy="320040"/>
+          </a:xfrm>
+          <a:prstGeom prst="rect">
+            <a:avLst/>
+          </a:prstGeom>
+          <a:noFill/>
+          <a:ln/>
+        </p:spPr>
+        <p:txBody>
+          <a:bodyPr wrap="square" lIns="0" tIns="0" rIns="0" bIns="0" rtlCol="0" anchor="ctr"/>
+          <a:lstStyle/>
+          <a:p>
+            <a:pPr algn="l" indent="0" marL="0">
+              <a:buNone/>
+            </a:pPr>
+            <a:r>
+              <a:rPr lang="en-US" sz="1500" b="1" dirty="0">
+                <a:solidFill>
+                  <a:srgbClr val="FFFFFF"/>
+                </a:solidFill>
+                <a:latin typeface="Calibri" pitchFamily="34" charset="0"/>
+                <a:ea typeface="Calibri" pitchFamily="34" charset="-122"/>
+                <a:cs typeface="Calibri" pitchFamily="34" charset="-120"/>
+              </a:rPr>
+              <a:t>Circle Gateway</a:t>
+            </a:r>
+            <a:endParaRPr lang="en-US" sz="1500" dirty="0"/>
+          </a:p>
+        </p:txBody>
+      </p:sp>
+      <p:sp>
+        <p:nvSpPr>
+          <p:cNvPr id="23" name="Text 21"/>
+          <p:cNvSpPr/>
+          <p:nvPr/>
+        </p:nvSpPr>
+        <p:spPr>
+          <a:xfrm>
+            <a:off x="1005840" y="4005072"/>
+            <a:ext cx="3200400" cy="502920"/>
+          </a:xfrm>
+          <a:prstGeom prst="rect">
+            <a:avLst/>
+          </a:prstGeom>
+          <a:noFill/>
+          <a:ln/>
+        </p:spPr>
+        <p:txBody>
+          <a:bodyPr wrap="square" lIns="0" tIns="0" rIns="0" bIns="0" rtlCol="0" anchor="ctr"/>
+          <a:lstStyle/>
+          <a:p>
+            <a:pPr algn="l" indent="0" marL="0">
+              <a:buNone/>
+            </a:pPr>
+            <a:r>
+              <a:rPr lang="en-US" sz="1100" dirty="0">
+                <a:solidFill>
+                  <a:srgbClr val="94A3B8"/>
+                </a:solidFill>
+                <a:latin typeface="Calibri" pitchFamily="34" charset="0"/>
+                <a:ea typeface="Calibri" pitchFamily="34" charset="-122"/>
+                <a:cs typeface="Calibri" pitchFamily="34" charset="-120"/>
+              </a:rPr>
+              <a:t>One-click Solana → Arc USDC bridge.</a:t>
+            </a:r>
+            <a:endParaRPr lang="en-US" sz="1100" dirty="0"/>
+          </a:p>
+          <a:p>
+            <a:pPr algn="l" indent="0" marL="0">
+              <a:buNone/>
+            </a:pPr>
+            <a:r>
+              <a:rPr lang="en-US" sz="1100" dirty="0">
+                <a:solidFill>
+                  <a:srgbClr val="94A3B8"/>
+                </a:solidFill>
+                <a:latin typeface="Calibri" pitchFamily="34" charset="0"/>
+                <a:ea typeface="Calibri" pitchFamily="34" charset="-122"/>
+                <a:cs typeface="Calibri" pitchFamily="34" charset="-120"/>
+              </a:rPr>
+              <a:t>2.5 USDC end-to-end in ~3s, 0.003 fee.</a:t>
+            </a:r>
+            <a:endParaRPr lang="en-US" sz="1100" dirty="0"/>
+          </a:p>
+        </p:txBody>
+      </p:sp>
+      <p:sp>
+        <p:nvSpPr>
+          <p:cNvPr id="24" name="Shape 22"/>
+          <p:cNvSpPr/>
+          <p:nvPr/>
+        </p:nvSpPr>
+        <p:spPr>
+          <a:xfrm>
+            <a:off x="4709160" y="3566160"/>
+            <a:ext cx="3703320" cy="960120"/>
+          </a:xfrm>
+          <a:prstGeom prst="rect">
+            <a:avLst/>
+          </a:prstGeom>
+          <a:solidFill>
+            <a:srgbClr val="141937"/>
+          </a:solidFill>
+          <a:ln/>
+          <a:effectLst>
+            <a:outerShdw sx="100000" sy="100000" kx="0" ky="0" algn="bl" rotWithShape="0" blurRad="101600" dist="38100" dir="8100000">
+              <a:srgbClr val="000000">
+                <a:alpha val="30000"/>
+              </a:srgbClr>
+            </a:outerShdw>
+          </a:effectLst>
+        </p:spPr>
+      </p:sp>
+      <p:sp>
+        <p:nvSpPr>
+          <p:cNvPr id="25" name="Shape 23"/>
+          <p:cNvSpPr/>
+          <p:nvPr/>
+        </p:nvSpPr>
+        <p:spPr>
+          <a:xfrm>
+            <a:off x="4709160" y="3566160"/>
+            <a:ext cx="64008" cy="960120"/>
+          </a:xfrm>
+          <a:prstGeom prst="rect">
+            <a:avLst/>
+          </a:prstGeom>
+          <a:solidFill>
+            <a:srgbClr val="2563EB"/>
+          </a:solidFill>
+          <a:ln/>
+        </p:spPr>
+      </p:sp>
+      <p:sp>
+        <p:nvSpPr>
+          <p:cNvPr id="26" name="Text 24"/>
+          <p:cNvSpPr/>
+          <p:nvPr/>
+        </p:nvSpPr>
+        <p:spPr>
+          <a:xfrm>
+            <a:off x="4983480" y="3657600"/>
+            <a:ext cx="3200400" cy="320040"/>
+          </a:xfrm>
+          <a:prstGeom prst="rect">
+            <a:avLst/>
+          </a:prstGeom>
+          <a:noFill/>
+          <a:ln/>
+        </p:spPr>
+        <p:txBody>
+          <a:bodyPr wrap="square" lIns="0" tIns="0" rIns="0" bIns="0" rtlCol="0" anchor="ctr"/>
+          <a:lstStyle/>
+          <a:p>
+            <a:pPr algn="l" indent="0" marL="0">
+              <a:buNone/>
+            </a:pPr>
+            <a:r>
+              <a:rPr lang="en-US" sz="1500" b="1" dirty="0">
+                <a:solidFill>
+                  <a:srgbClr val="FFFFFF"/>
+                </a:solidFill>
+                <a:latin typeface="Calibri" pitchFamily="34" charset="0"/>
+                <a:ea typeface="Calibri" pitchFamily="34" charset="-122"/>
+                <a:cs typeface="Calibri" pitchFamily="34" charset="-120"/>
+              </a:rPr>
+              <a:t>Sub-Second Finality</a:t>
+            </a:r>
+            <a:endParaRPr lang="en-US" sz="1500" dirty="0"/>
+          </a:p>
+        </p:txBody>
+      </p:sp>
+      <p:sp>
+        <p:nvSpPr>
+          <p:cNvPr id="27" name="Text 25"/>
+          <p:cNvSpPr/>
+          <p:nvPr/>
+        </p:nvSpPr>
+        <p:spPr>
+          <a:xfrm>
+            <a:off x="4983480" y="4005072"/>
+            <a:ext cx="3200400" cy="502920"/>
+          </a:xfrm>
+          <a:prstGeom prst="rect">
+            <a:avLst/>
+          </a:prstGeom>
+          <a:noFill/>
+          <a:ln/>
+        </p:spPr>
+        <p:txBody>
+          <a:bodyPr wrap="square" lIns="0" tIns="0" rIns="0" bIns="0" rtlCol="0" anchor="ctr"/>
+          <a:lstStyle/>
+          <a:p>
+            <a:pPr algn="l" indent="0" marL="0">
+              <a:buNone/>
+            </a:pPr>
+            <a:r>
+              <a:rPr lang="en-US" sz="1100" dirty="0">
+                <a:solidFill>
+                  <a:srgbClr val="94A3B8"/>
+                </a:solidFill>
+                <a:latin typeface="Calibri" pitchFamily="34" charset="0"/>
+                <a:ea typeface="Calibri" pitchFamily="34" charset="-122"/>
+                <a:cs typeface="Calibri" pitchFamily="34" charset="-120"/>
+              </a:rPr>
+              <a:t>60+ on-chain settlements in one demo.</a:t>
+            </a:r>
+            <a:endParaRPr lang="en-US" sz="1100" dirty="0"/>
+          </a:p>
+          <a:p>
+            <a:pPr algn="l" indent="0" marL="0">
+              <a:buNone/>
+            </a:pPr>
+            <a:r>
+              <a:rPr lang="en-US" sz="1100" dirty="0">
+                <a:solidFill>
+                  <a:srgbClr val="94A3B8"/>
+                </a:solidFill>
+                <a:latin typeface="Calibri" pitchFamily="34" charset="0"/>
+                <a:ea typeface="Calibri" pitchFamily="34" charset="-122"/>
+                <a:cs typeface="Calibri" pitchFamily="34" charset="-120"/>
+              </a:rPr>
+              <a:t>Would cost $180+ on Ethereum.</a:t>
+            </a:r>
+            <a:endParaRPr lang="en-US" sz="1100" dirty="0"/>
           </a:p>
         </p:txBody>
       </p:sp>

</xml_diff>